<commit_message>
Deck: slide 8 chapter times match the narrated 2:56 demo video
Co-Authored-By: Claude Opus 5.5 <noreply@anthropic.com>
</commit_message>
<xml_diff>
--- a/docs/submission/ResiliencePilot_Presentation.pptx
+++ b/docs/submission/ResiliencePilot_Presentation.pptx
@@ -14851,7 +14851,7 @@
                 </a:solidFill>
                 <a:latin typeface="Calibri"/>
               </a:rPr>
-              <a:t>2:40 live demo video</a:t>
+              <a:t>2:56 live demo video</a:t>
             </a:r>
           </a:p>
         </p:txBody>
@@ -14915,7 +14915,7 @@
                 </a:solidFill>
                 <a:latin typeface="Courier New"/>
               </a:rPr>
-              <a:t>0:33  </a:t>
+              <a:t>0:38  </a:t>
             </a:r>
             <a:r>
               <a:rPr sz="1100" b="0" i="0">
@@ -14940,7 +14940,7 @@
                 </a:solidFill>
                 <a:latin typeface="Courier New"/>
               </a:rPr>
-              <a:t>1:01  </a:t>
+              <a:t>1:07  </a:t>
             </a:r>
             <a:r>
               <a:rPr sz="1100" b="0" i="0">
@@ -14965,7 +14965,7 @@
                 </a:solidFill>
                 <a:latin typeface="Courier New"/>
               </a:rPr>
-              <a:t>1:22  </a:t>
+              <a:t>1:31  </a:t>
             </a:r>
             <a:r>
               <a:rPr sz="1100" b="0" i="0">
@@ -14990,7 +14990,7 @@
                 </a:solidFill>
                 <a:latin typeface="Courier New"/>
               </a:rPr>
-              <a:t>1:47  </a:t>
+              <a:t>1:57  </a:t>
             </a:r>
             <a:r>
               <a:rPr sz="1100" b="0" i="0">
@@ -15015,7 +15015,7 @@
                 </a:solidFill>
                 <a:latin typeface="Courier New"/>
               </a:rPr>
-              <a:t>2:20  </a:t>
+              <a:t>2:34  </a:t>
             </a:r>
             <a:r>
               <a:rPr sz="1100" b="0" i="0">

</xml_diff>

<commit_message>
Deck: chapter times for the re-narrated video
Co-Authored-By: Claude Opus 5.5 <noreply@anthropic.com>
</commit_message>
<xml_diff>
--- a/docs/submission/ResiliencePilot_Presentation.pptx
+++ b/docs/submission/ResiliencePilot_Presentation.pptx
@@ -14915,7 +14915,7 @@
                 </a:solidFill>
                 <a:latin typeface="Courier New"/>
               </a:rPr>
-              <a:t>0:38  </a:t>
+              <a:t>0:37  </a:t>
             </a:r>
             <a:r>
               <a:rPr sz="1100" b="0" i="0">
@@ -15015,7 +15015,7 @@
                 </a:solidFill>
                 <a:latin typeface="Courier New"/>
               </a:rPr>
-              <a:t>2:34  </a:t>
+              <a:t>2:33  </a:t>
             </a:r>
             <a:r>
               <a:rPr sz="1100" b="0" i="0">

</xml_diff>